<commit_message>
Embed high-resolution DBMS graphics and diagrams into Slide 6 of presentation
</commit_message>
<xml_diff>
--- a/AI_Wardrobe_DBMS_Project_Presentation.pptx
+++ b/AI_Wardrobe_DBMS_Project_Presentation.pptx
@@ -7301,12 +7301,20 @@
           </a:p>
         </p:txBody>
       </p:sp>
-      <p:sp>
-        <p:nvSpPr>
-          <p:cNvPr id="8" name="Rectangle 7"/>
-          <p:cNvSpPr/>
-          <p:nvPr/>
-        </p:nvSpPr>
+      <p:pic>
+        <p:nvPicPr>
+          <p:cNvPr id="8" name="Picture 7" descr="slide6_er_diagram.png"/>
+          <p:cNvPicPr>
+            <a:picLocks noChangeAspect="1"/>
+          </p:cNvPicPr>
+          <p:nvPr/>
+        </p:nvPicPr>
+        <p:blipFill>
+          <a:blip r:embed="rId2"/>
+          <a:stretch>
+            <a:fillRect/>
+          </a:stretch>
+        </p:blipFill>
         <p:spPr>
           <a:xfrm>
             <a:off x="731520" y="1554480"/>
@@ -7315,52 +7323,8 @@
           <a:prstGeom prst="rect">
             <a:avLst/>
           </a:prstGeom>
-          <a:solidFill>
-            <a:srgbClr val="FFFFFF"/>
-          </a:solidFill>
-          <a:ln>
-            <a:solidFill>
-              <a:srgbClr val="A8DAD2"/>
-            </a:solidFill>
-          </a:ln>
-        </p:spPr>
-        <p:style>
-          <a:lnRef idx="1">
-            <a:schemeClr val="accent1"/>
-          </a:lnRef>
-          <a:fillRef idx="3">
-            <a:schemeClr val="accent1"/>
-          </a:fillRef>
-          <a:effectRef idx="2">
-            <a:schemeClr val="accent1"/>
-          </a:effectRef>
-          <a:fontRef idx="minor">
-            <a:schemeClr val="lt1"/>
-          </a:fontRef>
-        </p:style>
-        <p:txBody>
-          <a:bodyPr rtlCol="0" anchor="ctr"/>
-          <a:lstStyle/>
-          <a:p>
-            <a:pPr algn="ctr">
-              <a:defRPr sz="1100">
-                <a:solidFill>
-                  <a:srgbClr val="285050"/>
-                </a:solidFill>
-                <a:latin typeface="Arial"/>
-              </a:defRPr>
-            </a:pPr>
-            <a:r>
-              <a:t>[ Database Output / Schema ]</a:t>
-            </a:r>
-            <a:br/>
-            <a:br/>
-            <a:r>
-              <a:t>3NF Relational ER Architecture</a:t>
-            </a:r>
-          </a:p>
-        </p:txBody>
-      </p:sp>
+        </p:spPr>
+      </p:pic>
       <p:sp>
         <p:nvSpPr>
           <p:cNvPr id="9" name="TextBox 8"/>
@@ -7440,12 +7404,20 @@
           </a:p>
         </p:txBody>
       </p:sp>
-      <p:sp>
-        <p:nvSpPr>
-          <p:cNvPr id="11" name="Rectangle 10"/>
-          <p:cNvSpPr/>
-          <p:nvPr/>
-        </p:nvSpPr>
+      <p:pic>
+        <p:nvPicPr>
+          <p:cNvPr id="11" name="Picture 10" descr="slide6_digital_closet_db.png"/>
+          <p:cNvPicPr>
+            <a:picLocks noChangeAspect="1"/>
+          </p:cNvPicPr>
+          <p:nvPr/>
+        </p:nvPicPr>
+        <p:blipFill>
+          <a:blip r:embed="rId3"/>
+          <a:stretch>
+            <a:fillRect/>
+          </a:stretch>
+        </p:blipFill>
         <p:spPr>
           <a:xfrm>
             <a:off x="4540910" y="1554480"/>
@@ -7454,52 +7426,8 @@
           <a:prstGeom prst="rect">
             <a:avLst/>
           </a:prstGeom>
-          <a:solidFill>
-            <a:srgbClr val="FFFFFF"/>
-          </a:solidFill>
-          <a:ln>
-            <a:solidFill>
-              <a:srgbClr val="A8DAD2"/>
-            </a:solidFill>
-          </a:ln>
-        </p:spPr>
-        <p:style>
-          <a:lnRef idx="1">
-            <a:schemeClr val="accent1"/>
-          </a:lnRef>
-          <a:fillRef idx="3">
-            <a:schemeClr val="accent1"/>
-          </a:fillRef>
-          <a:effectRef idx="2">
-            <a:schemeClr val="accent1"/>
-          </a:effectRef>
-          <a:fontRef idx="minor">
-            <a:schemeClr val="lt1"/>
-          </a:fontRef>
-        </p:style>
-        <p:txBody>
-          <a:bodyPr rtlCol="0" anchor="ctr"/>
-          <a:lstStyle/>
-          <a:p>
-            <a:pPr algn="ctr">
-              <a:defRPr sz="1100">
-                <a:solidFill>
-                  <a:srgbClr val="285050"/>
-                </a:solidFill>
-                <a:latin typeface="Arial"/>
-              </a:defRPr>
-            </a:pPr>
-            <a:r>
-              <a:t>[ Database Output / Schema ]</a:t>
-            </a:r>
-            <a:br/>
-            <a:br/>
-            <a:r>
-              <a:t>ACID Wardrobe Data Pipeline</a:t>
-            </a:r>
-          </a:p>
-        </p:txBody>
-      </p:sp>
+        </p:spPr>
+      </p:pic>
       <p:sp>
         <p:nvSpPr>
           <p:cNvPr id="12" name="TextBox 11"/>
@@ -7579,12 +7507,20 @@
           </a:p>
         </p:txBody>
       </p:sp>
-      <p:sp>
-        <p:nvSpPr>
-          <p:cNvPr id="14" name="Rectangle 13"/>
-          <p:cNvSpPr/>
-          <p:nvPr/>
-        </p:nvSpPr>
+      <p:pic>
+        <p:nvPicPr>
+          <p:cNvPr id="14" name="Picture 13" descr="slide6_query_state_machine.png"/>
+          <p:cNvPicPr>
+            <a:picLocks noChangeAspect="1"/>
+          </p:cNvPicPr>
+          <p:nvPr/>
+        </p:nvPicPr>
+        <p:blipFill>
+          <a:blip r:embed="rId4"/>
+          <a:stretch>
+            <a:fillRect/>
+          </a:stretch>
+        </p:blipFill>
         <p:spPr>
           <a:xfrm>
             <a:off x="8351215" y="1554480"/>
@@ -7593,52 +7529,8 @@
           <a:prstGeom prst="rect">
             <a:avLst/>
           </a:prstGeom>
-          <a:solidFill>
-            <a:srgbClr val="FFFFFF"/>
-          </a:solidFill>
-          <a:ln>
-            <a:solidFill>
-              <a:srgbClr val="A8DAD2"/>
-            </a:solidFill>
-          </a:ln>
-        </p:spPr>
-        <p:style>
-          <a:lnRef idx="1">
-            <a:schemeClr val="accent1"/>
-          </a:lnRef>
-          <a:fillRef idx="3">
-            <a:schemeClr val="accent1"/>
-          </a:fillRef>
-          <a:effectRef idx="2">
-            <a:schemeClr val="accent1"/>
-          </a:effectRef>
-          <a:fontRef idx="minor">
-            <a:schemeClr val="lt1"/>
-          </a:fontRef>
-        </p:style>
-        <p:txBody>
-          <a:bodyPr rtlCol="0" anchor="ctr"/>
-          <a:lstStyle/>
-          <a:p>
-            <a:pPr algn="ctr">
-              <a:defRPr sz="1100">
-                <a:solidFill>
-                  <a:srgbClr val="285050"/>
-                </a:solidFill>
-                <a:latin typeface="Arial"/>
-              </a:defRPr>
-            </a:pPr>
-            <a:r>
-              <a:t>[ Database Output / Schema ]</a:t>
-            </a:r>
-            <a:br/>
-            <a:br/>
-            <a:r>
-              <a:t>Query &amp; State Lifecycle Tracking</a:t>
-            </a:r>
-          </a:p>
-        </p:txBody>
-      </p:sp>
+        </p:spPr>
+      </p:pic>
       <p:sp>
         <p:nvSpPr>
           <p:cNvPr id="15" name="TextBox 14"/>

</xml_diff>